<commit_message>
Add academy scenario and year plan; credit Mateusz Pichal
- New: full scenariusz akademii na 11 listopada (running order, roles,
  repertoire, prep timeline, jasełka variant).
- New: roczny rozkład materiału / plan wynikowy for klasa 4 (~32 lessons
  mapped to podstawa programowa), rendered in landscape .docx.
- Insert author "Mateusz Pichal" into the presentation (title/closing),
  report, lesson plans, and repertoire pack.
- Update README with the two new documents.

Co-Authored-By: Claude Opus 4.8 <noreply@anthropic.com>
Claude-Session: https://claude.ai/code/session_01WrWnzjDS4gKGgSt3A294G4
</commit_message>
<xml_diff>
--- a/edukacja-muzyczna-szkola-podstawowa/prezentacja/Prezentacja-edukacja-muzyczna.pptx
+++ b/edukacja-muzyczna-szkola-podstawowa/prezentacja/Prezentacja-edukacja-muzyczna.pptx
@@ -3253,7 +3253,7 @@
                 </a:solidFill>
                 <a:latin typeface="Calibri"/>
               </a:rPr>
-              <a:t>Szkoła podstawowa · klasy 1–3, 4–7 oraz chór szkolny</a:t>
+              <a:t>Prowadzący: Mateusz Pichal</a:t>
             </a:r>
           </a:p>
           <a:p>
@@ -3264,7 +3264,7 @@
                 </a:solidFill>
                 <a:latin typeface="Calibri"/>
               </a:rPr>
-              <a:t>rok szkolny 2025/2026</a:t>
+              <a:t>Szkoła podstawowa · klasy 1–3, 4–7 oraz chór szkolny · rok szkolny 2025/2026</a:t>
             </a:r>
           </a:p>
         </p:txBody>
@@ -6457,7 +6457,7 @@
                 </a:solidFill>
                 <a:latin typeface="Calibri"/>
               </a:rPr>
-              <a:t>[imię i nazwisko] · [kontakt]</a:t>
+              <a:t>Mateusz Pichal · [kontakt]</a:t>
             </a:r>
           </a:p>
         </p:txBody>

</xml_diff>